<commit_message>
fix(pptx): fix two layout bugs in slides 4 and 6
Slide 4: remove 'tool-calls' label that overlapped with Qwen API box
Slide 6: replace full-width hline with short right-column connector
         so it no longer cuts through left-column bullet text

Co-Authored-By: Claude Sonnet 4.6 <noreply@anthropic.com>
</commit_message>
<xml_diff>
--- a/docs/Ops-Sentinel.pptx
+++ b/docs/Ops-Sentinel.pptx
@@ -5385,40 +5385,6 @@
         </p:nvSpPr>
         <p:spPr>
           <a:xfrm>
-            <a:off x="5532120" y="1481328"/>
-            <a:ext cx="822960" cy="274320"/>
-          </a:xfrm>
-          <a:prstGeom prst="rect">
-            <a:avLst/>
-          </a:prstGeom>
-          <a:noFill/>
-        </p:spPr>
-        <p:txBody>
-          <a:bodyPr wrap="square">
-            <a:spAutoFit/>
-          </a:bodyPr>
-          <a:lstStyle/>
-          <a:p>
-            <a:pPr algn="ctr"/>
-            <a:r>
-              <a:rPr sz="1000" b="0" i="0">
-                <a:solidFill>
-                  <a:srgbClr val="58A6FF"/>
-                </a:solidFill>
-              </a:rPr>
-              <a:t>tool-calls</a:t>
-            </a:r>
-          </a:p>
-        </p:txBody>
-      </p:sp>
-      <p:sp>
-        <p:nvSpPr>
-          <p:cNvPr id="21" name="TextBox 20"/>
-          <p:cNvSpPr txBox="1"/>
-          <p:nvPr/>
-        </p:nvSpPr>
-        <p:spPr>
-          <a:xfrm>
             <a:off x="320040" y="5989320"/>
             <a:ext cx="11430000" cy="365760"/>
           </a:xfrm>
@@ -6051,8 +6017,8 @@
         </p:nvSpPr>
         <p:spPr>
           <a:xfrm>
-            <a:off x="640080" y="1463040"/>
-            <a:ext cx="6217920" cy="667512"/>
+            <a:off x="640080" y="1508760"/>
+            <a:ext cx="6217920" cy="713232"/>
           </a:xfrm>
           <a:prstGeom prst="rect">
             <a:avLst/>
@@ -6085,8 +6051,8 @@
         </p:nvSpPr>
         <p:spPr>
           <a:xfrm>
-            <a:off x="640080" y="2039112"/>
-            <a:ext cx="6217920" cy="667512"/>
+            <a:off x="640080" y="2130552"/>
+            <a:ext cx="6217920" cy="713232"/>
           </a:xfrm>
           <a:prstGeom prst="rect">
             <a:avLst/>
@@ -6119,8 +6085,8 @@
         </p:nvSpPr>
         <p:spPr>
           <a:xfrm>
-            <a:off x="640080" y="2615184"/>
-            <a:ext cx="6217920" cy="667512"/>
+            <a:off x="640080" y="2752344"/>
+            <a:ext cx="6217920" cy="713232"/>
           </a:xfrm>
           <a:prstGeom prst="rect">
             <a:avLst/>
@@ -6153,8 +6119,8 @@
         </p:nvSpPr>
         <p:spPr>
           <a:xfrm>
-            <a:off x="640080" y="3191256"/>
-            <a:ext cx="6217920" cy="667512"/>
+            <a:off x="640080" y="3374136"/>
+            <a:ext cx="6217920" cy="713232"/>
           </a:xfrm>
           <a:prstGeom prst="rect">
             <a:avLst/>
@@ -6187,8 +6153,8 @@
         </p:nvSpPr>
         <p:spPr>
           <a:xfrm>
-            <a:off x="640080" y="3767328"/>
-            <a:ext cx="6217920" cy="667512"/>
+            <a:off x="640080" y="3995928"/>
+            <a:ext cx="6217920" cy="713232"/>
           </a:xfrm>
           <a:prstGeom prst="rect">
             <a:avLst/>
@@ -6368,15 +6334,15 @@
         </p:nvCxnSpPr>
         <p:spPr>
           <a:xfrm>
-            <a:off x="914171" y="2240280"/>
-            <a:ext cx="10360609" cy="0"/>
+            <a:off x="7178040" y="2240280"/>
+            <a:ext cx="4480560" cy="0"/>
           </a:xfrm>
           <a:prstGeom prst="line">
             <a:avLst/>
           </a:prstGeom>
-          <a:ln w="19050">
+          <a:ln w="12700">
             <a:solidFill>
-              <a:srgbClr val="58A6FF"/>
+              <a:srgbClr val="8B949E"/>
             </a:solidFill>
           </a:ln>
         </p:spPr>

</xml_diff>